<commit_message>
Hebrew deck: say what the 296 questions are (the Trainer's validation split), not that the model never saw them
Co-Authored-By: Claude Fable 5.1 <noreply@anthropic.com>
</commit_message>
<xml_diff>
--- a/slides_he.pptx
+++ b/slides_he.pptx
@@ -109,7 +109,7 @@
   <p:extLst>
     <p:ext uri="{521415D9-36F7-43E2-AB2F-B90AF26B5E84}">
       <p14:sectionLst xmlns:p14="http://schemas.microsoft.com/office/powerpoint/2010/main">
-        <p14:section name="שיפור האחזור" id="{a4cdccc2-b4bf-a706-5fee-5ed8061195fc}">
+        <p14:section name="שיפור האחזור" id="{5bd61881-9cd6-8ccf-d55b-a953db4a1756}">
           <p14:sldIdLst>
             <p14:sldId id="256"/>
             <p14:sldId id="257"/>
@@ -151,7 +151,7 @@
                 </a:solidFill>
                 <a:latin typeface="+mn-lt"/>
               </a:rPr>
-              <a:t>296 שאלות שלא נראו באימון, מאגר מלא (%)</a:t>
+              <a:t>296 שאלות סט האימות של קוד האימון (seed 42), מאגר מלא (%)</a:t>
             </a:r>
           </a:p>
         </c:rich>
@@ -906,7 +906,7 @@
           <a:p>
             <a:r>
               <a:rPr lang="en-US" dirty="0"/>
-              <a:t>המצב הקיים נמדד על המאגר המלא, 296 שאלות שלא נראו באימון (החלוקה של קוד האימון עצמו, seed 42). קריאת הכשלים קדמה לבחירת כיוון.</a:t>
+              <a:t>המצב הקיים נמדד על המאגר המלא, 296 שאלות סט האימות שקוד האימון של Webiks מפריש (10%, seed 42); האם המודל שפורסם ראה אותן לא ידוע, הבריף אומר שהקובץ כולו שימש לאימון. קריאת הכשלים קדמה לבחירת כיוון.</a:t>
             </a:r>
             <a:endParaRPr lang="en-US" dirty="0"/>
           </a:p>

</xml_diff>